<commit_message>
Update mini project files
</commit_message>
<xml_diff>
--- a/PROJECT/QuickDraw_Mini_Project_Presentation.pptx
+++ b/PROJECT/QuickDraw_Mini_Project_Presentation.pptx
@@ -5,7 +5,7 @@
     <p:sldMasterId id="2147483648" r:id="rId1"/>
   </p:sldMasterIdLst>
   <p:notesMasterIdLst>
-    <p:notesMasterId r:id="rId13"/>
+    <p:notesMasterId r:id="rId12"/>
   </p:notesMasterIdLst>
   <p:sldIdLst>
     <p:sldId id="256" r:id="rId2"/>
@@ -15,10 +15,9 @@
     <p:sldId id="260" r:id="rId6"/>
     <p:sldId id="261" r:id="rId7"/>
     <p:sldId id="262" r:id="rId8"/>
-    <p:sldId id="263" r:id="rId9"/>
-    <p:sldId id="264" r:id="rId10"/>
-    <p:sldId id="265" r:id="rId11"/>
-    <p:sldId id="266" r:id="rId12"/>
+    <p:sldId id="264" r:id="rId9"/>
+    <p:sldId id="265" r:id="rId10"/>
+    <p:sldId id="266" r:id="rId11"/>
   </p:sldIdLst>
   <p:sldSz cx="9144000" cy="5143500" type="screen16x9"/>
   <p:notesSz cx="5143500" cy="9144000"/>
@@ -758,10 +757,7 @@
           <a:bodyPr/>
           <a:lstStyle/>
           <a:p>
-            <a:r>
-              <a:rPr lang="en-US" dirty="0"/>
-              <a:t>Be upfront about limitations; the panel usually asks about the SVM iteration cap and the missing validation tracking.</a:t>
-            </a:r>
+            <a:endParaRPr lang="en-US" dirty="0"/>
           </a:p>
         </p:txBody>
       </p:sp>
@@ -783,90 +779,6 @@
             <a:fld id="{F7021451-1387-4CA6-816F-3879F97B5CBC}" type="slidenum">
               <a:rPr lang="en-US"/>
               <a:t>10</a:t>
-            </a:fld>
-            <a:endParaRPr lang="en-US"/>
-          </a:p>
-        </p:txBody>
-      </p:sp>
-    </p:spTree>
-    <p:extLst>
-      <p:ext uri="{BB962C8B-B14F-4D97-AF65-F5344CB8AC3E}">
-        <p14:creationId xmlns:p14="http://schemas.microsoft.com/office/powerpoint/2010/main" val="1024086991"/>
-      </p:ext>
-    </p:extLst>
-  </p:cSld>
-  <p:clrMapOvr>
-    <a:masterClrMapping/>
-  </p:clrMapOvr>
-</p:notes>
-</file>
-
-<file path=ppt/notesSlides/notesSlide11.xml><?xml version="1.0" encoding="utf-8"?>
-<p:notes xmlns:a="http://schemas.openxmlformats.org/drawingml/2006/main" xmlns:r="http://schemas.openxmlformats.org/officeDocument/2006/relationships" xmlns:p="http://schemas.openxmlformats.org/presentationml/2006/main">
-  <p:cSld>
-    <p:spTree>
-      <p:nvGrpSpPr>
-        <p:cNvPr id="1" name=""/>
-        <p:cNvGrpSpPr/>
-        <p:nvPr/>
-      </p:nvGrpSpPr>
-      <p:grpSpPr>
-        <a:xfrm>
-          <a:off x="0" y="0"/>
-          <a:ext cx="0" cy="0"/>
-          <a:chOff x="0" y="0"/>
-          <a:chExt cx="0" cy="0"/>
-        </a:xfrm>
-      </p:grpSpPr>
-      <p:sp>
-        <p:nvSpPr>
-          <p:cNvPr id="2" name="Slide Image Placeholder 1"/>
-          <p:cNvSpPr>
-            <a:spLocks noGrp="1" noRot="1" noChangeAspect="1"/>
-          </p:cNvSpPr>
-          <p:nvPr>
-            <p:ph type="sldImg"/>
-          </p:nvPr>
-        </p:nvSpPr>
-        <p:spPr/>
-      </p:sp>
-      <p:sp>
-        <p:nvSpPr>
-          <p:cNvPr id="3" name="Notes Placeholder 2"/>
-          <p:cNvSpPr>
-            <a:spLocks noGrp="1"/>
-          </p:cNvSpPr>
-          <p:nvPr>
-            <p:ph type="body" idx="1"/>
-          </p:nvPr>
-        </p:nvSpPr>
-        <p:spPr/>
-        <p:txBody>
-          <a:bodyPr/>
-          <a:lstStyle/>
-          <a:p>
-            <a:endParaRPr lang="en-US" dirty="0"/>
-          </a:p>
-        </p:txBody>
-      </p:sp>
-      <p:sp>
-        <p:nvSpPr>
-          <p:cNvPr id="4" name="Slide Number Placeholder 3"/>
-          <p:cNvSpPr>
-            <a:spLocks noGrp="1"/>
-          </p:cNvSpPr>
-          <p:nvPr>
-            <p:ph type="sldNum" sz="quarter" idx="10"/>
-          </p:nvPr>
-        </p:nvSpPr>
-        <p:spPr/>
-        <p:txBody>
-          <a:bodyPr/>
-          <a:lstStyle/>
-          <a:p>
-            <a:fld id="{F7021451-1387-4CA6-816F-3879F97B5CBC}" type="slidenum">
-              <a:rPr lang="en-US"/>
-              <a:t>11</a:t>
             </a:fld>
             <a:endParaRPr lang="en-US"/>
           </a:p>
@@ -1453,7 +1365,7 @@
           <a:p>
             <a:r>
               <a:rPr lang="en-US" dirty="0"/>
-              <a:t>Rows are true classes, columns are predicted classes. Mosquito is the most distinctive shape; the CNN roughly cuts the banana/hockey-stick confusion by 5x vs logistic regression.</a:t>
+              <a:t>Inference time is for the full 6,000-image test set. CNN training: 20 epochs, 679.45 s.</a:t>
             </a:r>
           </a:p>
         </p:txBody>
@@ -1540,7 +1452,7 @@
           <a:p>
             <a:r>
               <a:rPr lang="en-US" dirty="0"/>
-              <a:t>Inference time is for the full 6,000-image test set. CNN training: 20 epochs, 679.45 s.</a:t>
+              <a:t>Be upfront about limitations; the panel usually asks about the SVM iteration cap and the missing validation tracking.</a:t>
             </a:r>
           </a:p>
         </p:txBody>
@@ -2220,7 +2132,7 @@
                 <a:ea typeface="Cambria" pitchFamily="34" charset="-122"/>
                 <a:cs typeface="Cambria" pitchFamily="34" charset="-120"/>
               </a:rPr>
-              <a:t>Recognising Doodles: Banana, Hockey Stick or Mosquito?</a:t>
+              <a:t>Recognising Doodles: Banana, Hockey Stick or Mosquito? </a:t>
             </a:r>
             <a:endParaRPr lang="en-US" sz="3400" dirty="0"/>
           </a:p>
@@ -2403,463 +2315,6 @@
 </file>
 
 <file path=ppt/slides/slide10.xml><?xml version="1.0" encoding="utf-8"?>
-<p:sld xmlns:a="http://schemas.openxmlformats.org/drawingml/2006/main" xmlns:r="http://schemas.openxmlformats.org/officeDocument/2006/relationships" xmlns:p="http://schemas.openxmlformats.org/presentationml/2006/main">
-  <p:cSld name="Slide 10">
-    <p:spTree>
-      <p:nvGrpSpPr>
-        <p:cNvPr id="1" name=""/>
-        <p:cNvGrpSpPr/>
-        <p:nvPr/>
-      </p:nvGrpSpPr>
-      <p:grpSpPr>
-        <a:xfrm>
-          <a:off x="0" y="0"/>
-          <a:ext cx="0" cy="0"/>
-          <a:chOff x="0" y="0"/>
-          <a:chExt cx="0" cy="0"/>
-        </a:xfrm>
-      </p:grpSpPr>
-      <p:sp>
-        <p:nvSpPr>
-          <p:cNvPr id="2" name="Text 0"/>
-          <p:cNvSpPr>
-            <a:spLocks noGrp="1"/>
-          </p:cNvSpPr>
-          <p:nvPr>
-            <p:ph type="title" idx="100" hasCustomPrompt="1"/>
-          </p:nvPr>
-        </p:nvSpPr>
-        <p:spPr>
-          <a:xfrm>
-            <a:off x="457200" y="274320"/>
-            <a:ext cx="8229600" cy="731520"/>
-          </a:xfrm>
-          <a:prstGeom prst="rect">
-            <a:avLst/>
-          </a:prstGeom>
-          <a:noFill/>
-          <a:ln/>
-        </p:spPr>
-        <p:txBody>
-          <a:bodyPr wrap="square" lIns="0" tIns="0" rIns="0" bIns="0" rtlCol="0" anchor="ctr"/>
-          <a:lstStyle/>
-          <a:p>
-            <a:pPr marL="0" indent="0" algn="l">
-              <a:buNone/>
-            </a:pPr>
-            <a:r>
-              <a:rPr lang="en-US" sz="2600" b="1" dirty="0">
-                <a:solidFill>
-                  <a:schemeClr val="tx1"/>
-                </a:solidFill>
-                <a:latin typeface="Cambria" pitchFamily="34" charset="0"/>
-                <a:ea typeface="Cambria" pitchFamily="34" charset="-122"/>
-                <a:cs typeface="Cambria" pitchFamily="34" charset="-120"/>
-              </a:rPr>
-              <a:t>Conclusions and limitations</a:t>
-            </a:r>
-            <a:endParaRPr lang="en-US" sz="2600" dirty="0"/>
-          </a:p>
-        </p:txBody>
-      </p:sp>
-      <p:sp>
-        <p:nvSpPr>
-          <p:cNvPr id="3" name="Shape 1"/>
-          <p:cNvSpPr/>
-          <p:nvPr/>
-        </p:nvSpPr>
-        <p:spPr>
-          <a:xfrm>
-            <a:off x="457200" y="1188720"/>
-            <a:ext cx="4023360" cy="3383280"/>
-          </a:xfrm>
-          <a:prstGeom prst="roundRect">
-            <a:avLst>
-              <a:gd name="adj" fmla="val 3243"/>
-            </a:avLst>
-          </a:prstGeom>
-          <a:solidFill>
-            <a:schemeClr val="bg2"/>
-          </a:solidFill>
-          <a:ln w="12700">
-            <a:solidFill>
-              <a:schemeClr val="bg2"/>
-            </a:solidFill>
-            <a:prstDash val="solid"/>
-          </a:ln>
-        </p:spPr>
-      </p:sp>
-      <p:sp>
-        <p:nvSpPr>
-          <p:cNvPr id="4" name="Shape 2"/>
-          <p:cNvSpPr/>
-          <p:nvPr/>
-        </p:nvSpPr>
-        <p:spPr>
-          <a:xfrm>
-            <a:off x="4663440" y="1188720"/>
-            <a:ext cx="4023360" cy="3383280"/>
-          </a:xfrm>
-          <a:prstGeom prst="roundRect">
-            <a:avLst>
-              <a:gd name="adj" fmla="val 3243"/>
-            </a:avLst>
-          </a:prstGeom>
-          <a:solidFill>
-            <a:schemeClr val="bg2"/>
-          </a:solidFill>
-          <a:ln w="12700">
-            <a:solidFill>
-              <a:schemeClr val="bg2"/>
-            </a:solidFill>
-            <a:prstDash val="solid"/>
-          </a:ln>
-        </p:spPr>
-      </p:sp>
-      <p:sp>
-        <p:nvSpPr>
-          <p:cNvPr id="5" name="Text 3"/>
-          <p:cNvSpPr txBox="1"/>
-          <p:nvPr/>
-        </p:nvSpPr>
-        <p:spPr>
-          <a:xfrm>
-            <a:off x="685800" y="1325880"/>
-            <a:ext cx="3566160" cy="365760"/>
-          </a:xfrm>
-          <a:prstGeom prst="rect">
-            <a:avLst/>
-          </a:prstGeom>
-          <a:noFill/>
-          <a:ln/>
-        </p:spPr>
-        <p:txBody>
-          <a:bodyPr wrap="square" lIns="0" tIns="0" rIns="0" bIns="0" rtlCol="0" anchor="ctr"/>
-          <a:lstStyle/>
-          <a:p>
-            <a:pPr marL="0" indent="0">
-              <a:buNone/>
-            </a:pPr>
-            <a:r>
-              <a:rPr lang="en-US" sz="1800" b="1" dirty="0">
-                <a:solidFill>
-                  <a:schemeClr val="accent2"/>
-                </a:solidFill>
-                <a:latin typeface="Calibri" pitchFamily="34" charset="0"/>
-                <a:ea typeface="Calibri" pitchFamily="34" charset="-122"/>
-                <a:cs typeface="Calibri" pitchFamily="34" charset="-120"/>
-              </a:rPr>
-              <a:t>What we found</a:t>
-            </a:r>
-            <a:endParaRPr lang="en-US" sz="1800" dirty="0"/>
-          </a:p>
-        </p:txBody>
-      </p:sp>
-      <p:sp>
-        <p:nvSpPr>
-          <p:cNvPr id="6" name="Text 4"/>
-          <p:cNvSpPr txBox="1"/>
-          <p:nvPr/>
-        </p:nvSpPr>
-        <p:spPr>
-          <a:xfrm>
-            <a:off x="685800" y="1783080"/>
-            <a:ext cx="3611880" cy="2697480"/>
-          </a:xfrm>
-          <a:prstGeom prst="rect">
-            <a:avLst/>
-          </a:prstGeom>
-          <a:noFill/>
-          <a:ln/>
-        </p:spPr>
-        <p:txBody>
-          <a:bodyPr wrap="square" lIns="0" tIns="0" rIns="0" bIns="0" rtlCol="0" anchor="t"/>
-          <a:lstStyle/>
-          <a:p>
-            <a:pPr marL="342900" indent="-342900">
-              <a:spcAft>
-                <a:spcPts val="800"/>
-              </a:spcAft>
-              <a:buSzPct val="100000"/>
-              <a:buChar char="•"/>
-            </a:pPr>
-            <a:r>
-              <a:rPr lang="en-US" sz="1400" dirty="0">
-                <a:solidFill>
-                  <a:schemeClr val="tx1"/>
-                </a:solidFill>
-                <a:latin typeface="Calibri" pitchFamily="34" charset="0"/>
-                <a:ea typeface="Calibri" pitchFamily="34" charset="-122"/>
-                <a:cs typeface="Calibri" pitchFamily="34" charset="-120"/>
-              </a:rPr>
-              <a:t>CNN wins on every metric (95.0% accuracy)</a:t>
-            </a:r>
-            <a:endParaRPr lang="en-US" sz="1400" dirty="0"/>
-          </a:p>
-          <a:p>
-            <a:pPr marL="342900" indent="-342900">
-              <a:spcAft>
-                <a:spcPts val="800"/>
-              </a:spcAft>
-              <a:buSzPct val="100000"/>
-              <a:buChar char="•"/>
-            </a:pPr>
-            <a:r>
-              <a:rPr lang="en-US" sz="1400" dirty="0">
-                <a:solidFill>
-                  <a:schemeClr val="tx1"/>
-                </a:solidFill>
-                <a:latin typeface="Calibri" pitchFamily="34" charset="0"/>
-                <a:ea typeface="Calibri" pitchFamily="34" charset="-122"/>
-                <a:cs typeface="Calibri" pitchFamily="34" charset="-120"/>
-              </a:rPr>
-              <a:t>Spatial features beat raw-pixel models on sketches</a:t>
-            </a:r>
-            <a:endParaRPr lang="en-US" sz="1400" dirty="0"/>
-          </a:p>
-          <a:p>
-            <a:pPr marL="342900" indent="-342900">
-              <a:spcAft>
-                <a:spcPts val="800"/>
-              </a:spcAft>
-              <a:buSzPct val="100000"/>
-              <a:buChar char="•"/>
-            </a:pPr>
-            <a:r>
-              <a:rPr lang="en-US" sz="1400" dirty="0">
-                <a:solidFill>
-                  <a:schemeClr val="tx1"/>
-                </a:solidFill>
-                <a:latin typeface="Calibri" pitchFamily="34" charset="0"/>
-                <a:ea typeface="Calibri" pitchFamily="34" charset="-122"/>
-                <a:cs typeface="Calibri" pitchFamily="34" charset="-120"/>
-              </a:rPr>
-              <a:t>RBF is the only SVM kernel competitive with logistic regression</a:t>
-            </a:r>
-            <a:endParaRPr lang="en-US" sz="1400" dirty="0"/>
-          </a:p>
-          <a:p>
-            <a:pPr marL="342900" indent="-342900">
-              <a:spcAft>
-                <a:spcPts val="800"/>
-              </a:spcAft>
-              <a:buSzPct val="100000"/>
-              <a:buChar char="•"/>
-            </a:pPr>
-            <a:r>
-              <a:rPr lang="en-US" sz="1400" dirty="0">
-                <a:solidFill>
-                  <a:schemeClr val="tx1"/>
-                </a:solidFill>
-                <a:latin typeface="Calibri" pitchFamily="34" charset="0"/>
-                <a:ea typeface="Calibri" pitchFamily="34" charset="-122"/>
-                <a:cs typeface="Calibri" pitchFamily="34" charset="-120"/>
-              </a:rPr>
-              <a:t>Banana vs hockey stick is the hardest pair</a:t>
-            </a:r>
-            <a:endParaRPr lang="en-US" sz="1400" dirty="0"/>
-          </a:p>
-        </p:txBody>
-      </p:sp>
-      <p:sp>
-        <p:nvSpPr>
-          <p:cNvPr id="7" name="Text 5"/>
-          <p:cNvSpPr txBox="1"/>
-          <p:nvPr/>
-        </p:nvSpPr>
-        <p:spPr>
-          <a:xfrm>
-            <a:off x="4892040" y="1325880"/>
-            <a:ext cx="3566160" cy="365760"/>
-          </a:xfrm>
-          <a:prstGeom prst="rect">
-            <a:avLst/>
-          </a:prstGeom>
-          <a:noFill/>
-          <a:ln/>
-        </p:spPr>
-        <p:txBody>
-          <a:bodyPr wrap="square" lIns="0" tIns="0" rIns="0" bIns="0" rtlCol="0" anchor="ctr"/>
-          <a:lstStyle/>
-          <a:p>
-            <a:pPr marL="0" indent="0">
-              <a:buNone/>
-            </a:pPr>
-            <a:r>
-              <a:rPr lang="en-US" sz="1800" b="1" dirty="0">
-                <a:solidFill>
-                  <a:schemeClr val="accent3"/>
-                </a:solidFill>
-                <a:latin typeface="Calibri" pitchFamily="34" charset="0"/>
-                <a:ea typeface="Calibri" pitchFamily="34" charset="-122"/>
-                <a:cs typeface="Calibri" pitchFamily="34" charset="-120"/>
-              </a:rPr>
-              <a:t>Caveats and next steps</a:t>
-            </a:r>
-            <a:endParaRPr lang="en-US" sz="1800" dirty="0"/>
-          </a:p>
-        </p:txBody>
-      </p:sp>
-      <p:sp>
-        <p:nvSpPr>
-          <p:cNvPr id="8" name="Text 6"/>
-          <p:cNvSpPr txBox="1"/>
-          <p:nvPr/>
-        </p:nvSpPr>
-        <p:spPr>
-          <a:xfrm>
-            <a:off x="4892040" y="1783080"/>
-            <a:ext cx="3611880" cy="2697480"/>
-          </a:xfrm>
-          <a:prstGeom prst="rect">
-            <a:avLst/>
-          </a:prstGeom>
-          <a:noFill/>
-          <a:ln/>
-        </p:spPr>
-        <p:txBody>
-          <a:bodyPr wrap="square" lIns="0" tIns="0" rIns="0" bIns="0" rtlCol="0" anchor="t"/>
-          <a:lstStyle/>
-          <a:p>
-            <a:pPr marL="342900" indent="-342900">
-              <a:spcAft>
-                <a:spcPts val="800"/>
-              </a:spcAft>
-              <a:buSzPct val="100000"/>
-              <a:buChar char="•"/>
-            </a:pPr>
-            <a:r>
-              <a:rPr lang="en-US" sz="1400" dirty="0">
-                <a:solidFill>
-                  <a:schemeClr val="tx1"/>
-                </a:solidFill>
-                <a:latin typeface="Calibri" pitchFamily="34" charset="0"/>
-                <a:ea typeface="Calibri" pitchFamily="34" charset="-122"/>
-                <a:cs typeface="Calibri" pitchFamily="34" charset="-120"/>
-              </a:rPr>
-              <a:t>SVMs hit the 500-iteration cap and were untuned</a:t>
-            </a:r>
-            <a:endParaRPr lang="en-US" sz="1400" dirty="0"/>
-          </a:p>
-          <a:p>
-            <a:pPr marL="342900" indent="-342900">
-              <a:spcAft>
-                <a:spcPts val="800"/>
-              </a:spcAft>
-              <a:buSzPct val="100000"/>
-              <a:buChar char="•"/>
-            </a:pPr>
-            <a:r>
-              <a:rPr lang="en-US" sz="1400" dirty="0">
-                <a:solidFill>
-                  <a:schemeClr val="tx1"/>
-                </a:solidFill>
-                <a:latin typeface="Calibri" pitchFamily="34" charset="0"/>
-                <a:ea typeface="Calibri" pitchFamily="34" charset="-122"/>
-                <a:cs typeface="Calibri" pitchFamily="34" charset="-120"/>
-              </a:rPr>
-              <a:t>No validation curves, so overfitting is unmeasured</a:t>
-            </a:r>
-            <a:endParaRPr lang="en-US" sz="1400" dirty="0"/>
-          </a:p>
-          <a:p>
-            <a:pPr marL="342900" indent="-342900">
-              <a:spcAft>
-                <a:spcPts val="800"/>
-              </a:spcAft>
-              <a:buSzPct val="100000"/>
-              <a:buChar char="•"/>
-            </a:pPr>
-            <a:r>
-              <a:rPr lang="en-US" sz="1400" dirty="0">
-                <a:solidFill>
-                  <a:schemeClr val="tx1"/>
-                </a:solidFill>
-                <a:latin typeface="Calibri" pitchFamily="34" charset="0"/>
-                <a:ea typeface="Calibri" pitchFamily="34" charset="-122"/>
-                <a:cs typeface="Calibri" pitchFamily="34" charset="-120"/>
-              </a:rPr>
-              <a:t>Transfer learning not run: pretrained weights are outside the three allowed inputs</a:t>
-            </a:r>
-            <a:endParaRPr lang="en-US" sz="1400" dirty="0"/>
-          </a:p>
-          <a:p>
-            <a:pPr marL="342900" indent="-342900">
-              <a:spcAft>
-                <a:spcPts val="800"/>
-              </a:spcAft>
-              <a:buSzPct val="100000"/>
-              <a:buChar char="•"/>
-            </a:pPr>
-            <a:r>
-              <a:rPr lang="en-US" sz="1400" dirty="0">
-                <a:solidFill>
-                  <a:schemeClr val="tx1"/>
-                </a:solidFill>
-                <a:latin typeface="Calibri" pitchFamily="34" charset="0"/>
-                <a:ea typeface="Calibri" pitchFamily="34" charset="-122"/>
-                <a:cs typeface="Calibri" pitchFamily="34" charset="-120"/>
-              </a:rPr>
-              <a:t>Next: tune SVMs, add augmentation and early stopping</a:t>
-            </a:r>
-            <a:endParaRPr lang="en-US" sz="1400" dirty="0"/>
-          </a:p>
-        </p:txBody>
-      </p:sp>
-      <p:sp>
-        <p:nvSpPr>
-          <p:cNvPr id="25" name="Slide Number Placeholder 0"/>
-          <p:cNvSpPr>
-            <a:spLocks noGrp="1"/>
-          </p:cNvSpPr>
-          <p:nvPr>
-            <p:ph type="sldNum" sz="quarter" idx="4294967295"/>
-          </p:nvPr>
-        </p:nvSpPr>
-        <p:spPr>
-          <a:xfrm>
-            <a:off x="8229600" y="4800600"/>
-            <a:ext cx="457200" cy="228600"/>
-          </a:xfrm>
-          <a:prstGeom prst="rect">
-            <a:avLst/>
-          </a:prstGeom>
-          <a:extLst>
-            <a:ext uri="{C572A759-6A51-4108-AA02-DFA0A04FC94B}">
-              <ma14:wrappingTextBoxFlag xmlns:ma14="http://schemas.microsoft.com/office/mac/drawingml/2011/main" xmlns="" val="0"/>
-            </a:ext>
-          </a:extLst>
-        </p:spPr>
-        <p:txBody>
-          <a:bodyPr/>
-          <a:lstStyle>
-            <a:lvl1pPr>
-              <a:defRPr sz="1000">
-                <a:solidFill>
-                  <a:schemeClr val="accent5"/>
-                </a:solidFill>
-              </a:defRPr>
-            </a:lvl1pPr>
-          </a:lstStyle>
-          <a:p>
-            <a:pPr algn="r"/>
-            <a:fld id="{F7021451-1387-4CA6-816F-3879F97B5CBC}" type="slidenum">
-              <a:rPr lang="en-US" b="0"/>
-              <a:t>10</a:t>
-            </a:fld>
-            <a:endParaRPr lang="en-US"/>
-          </a:p>
-        </p:txBody>
-      </p:sp>
-    </p:spTree>
-  </p:cSld>
-  <p:clrMapOvr>
-    <a:masterClrMapping/>
-  </p:clrMapOvr>
-</p:sld>
-</file>
-
-<file path=ppt/slides/slide11.xml><?xml version="1.0" encoding="utf-8"?>
 <p:sld xmlns:a="http://schemas.openxmlformats.org/drawingml/2006/main" xmlns:r="http://schemas.openxmlformats.org/officeDocument/2006/relationships" xmlns:p="http://schemas.openxmlformats.org/presentationml/2006/main">
   <p:cSld name="Slide 11">
     <p:spTree>
@@ -3600,7 +3055,7 @@
                 <a:ea typeface="Cambria" pitchFamily="34" charset="-122"/>
                 <a:cs typeface="Cambria" pitchFamily="34" charset="-120"/>
               </a:rPr>
-              <a:t>Dataset: 20,000 Quick, Draw! sketches per class</a:t>
+              <a:t>Dataset: Google Quick, Draw! 20,000 sketches per class</a:t>
             </a:r>
             <a:endParaRPr lang="en-US" sz="2600" dirty="0"/>
           </a:p>
@@ -7246,299 +6701,6 @@
 </file>
 
 <file path=ppt/slides/slide8.xml><?xml version="1.0" encoding="utf-8"?>
-<p:sld xmlns:a="http://schemas.openxmlformats.org/drawingml/2006/main" xmlns:r="http://schemas.openxmlformats.org/officeDocument/2006/relationships" xmlns:p="http://schemas.openxmlformats.org/presentationml/2006/main">
-  <p:cSld name="Slide 8">
-    <p:spTree>
-      <p:nvGrpSpPr>
-        <p:cNvPr id="1" name=""/>
-        <p:cNvGrpSpPr/>
-        <p:nvPr/>
-      </p:nvGrpSpPr>
-      <p:grpSpPr>
-        <a:xfrm>
-          <a:off x="0" y="0"/>
-          <a:ext cx="0" cy="0"/>
-          <a:chOff x="0" y="0"/>
-          <a:chExt cx="0" cy="0"/>
-        </a:xfrm>
-      </p:grpSpPr>
-      <p:sp>
-        <p:nvSpPr>
-          <p:cNvPr id="2" name="Text 0"/>
-          <p:cNvSpPr>
-            <a:spLocks noGrp="1"/>
-          </p:cNvSpPr>
-          <p:nvPr>
-            <p:ph type="title" idx="100" hasCustomPrompt="1"/>
-          </p:nvPr>
-        </p:nvSpPr>
-        <p:spPr>
-          <a:xfrm>
-            <a:off x="457200" y="274320"/>
-            <a:ext cx="8229600" cy="731520"/>
-          </a:xfrm>
-          <a:prstGeom prst="rect">
-            <a:avLst/>
-          </a:prstGeom>
-          <a:noFill/>
-          <a:ln/>
-        </p:spPr>
-        <p:txBody>
-          <a:bodyPr wrap="square" lIns="0" tIns="0" rIns="0" bIns="0" rtlCol="0" anchor="ctr"/>
-          <a:lstStyle/>
-          <a:p>
-            <a:pPr marL="0" indent="0" algn="l">
-              <a:buNone/>
-            </a:pPr>
-            <a:r>
-              <a:rPr lang="en-US" sz="2600" b="1" dirty="0">
-                <a:solidFill>
-                  <a:schemeClr val="tx1"/>
-                </a:solidFill>
-                <a:latin typeface="Cambria" pitchFamily="34" charset="0"/>
-                <a:ea typeface="Cambria" pitchFamily="34" charset="-122"/>
-                <a:cs typeface="Cambria" pitchFamily="34" charset="-120"/>
-              </a:rPr>
-              <a:t>Most errors: banana vs hockey stick</a:t>
-            </a:r>
-            <a:endParaRPr lang="en-US" sz="2600" dirty="0"/>
-          </a:p>
-        </p:txBody>
-      </p:sp>
-      <p:sp>
-        <p:nvSpPr>
-          <p:cNvPr id="3" name="Shape 1"/>
-          <p:cNvSpPr/>
-          <p:nvPr/>
-        </p:nvSpPr>
-        <p:spPr>
-          <a:xfrm>
-            <a:off x="457200" y="1188720"/>
-            <a:ext cx="3931920" cy="3429000"/>
-          </a:xfrm>
-          <a:prstGeom prst="roundRect">
-            <a:avLst>
-              <a:gd name="adj" fmla="val 3200"/>
-            </a:avLst>
-          </a:prstGeom>
-          <a:solidFill>
-            <a:schemeClr val="bg2"/>
-          </a:solidFill>
-          <a:ln w="12700">
-            <a:solidFill>
-              <a:schemeClr val="bg2"/>
-            </a:solidFill>
-            <a:prstDash val="solid"/>
-          </a:ln>
-        </p:spPr>
-      </p:sp>
-      <p:sp>
-        <p:nvSpPr>
-          <p:cNvPr id="4" name="Shape 2"/>
-          <p:cNvSpPr/>
-          <p:nvPr/>
-        </p:nvSpPr>
-        <p:spPr>
-          <a:xfrm>
-            <a:off x="4754880" y="1188720"/>
-            <a:ext cx="3931920" cy="3429000"/>
-          </a:xfrm>
-          <a:prstGeom prst="roundRect">
-            <a:avLst>
-              <a:gd name="adj" fmla="val 3200"/>
-            </a:avLst>
-          </a:prstGeom>
-          <a:solidFill>
-            <a:schemeClr val="bg2"/>
-          </a:solidFill>
-          <a:ln w="12700">
-            <a:solidFill>
-              <a:schemeClr val="bg2"/>
-            </a:solidFill>
-            <a:prstDash val="solid"/>
-          </a:ln>
-        </p:spPr>
-      </p:sp>
-      <p:pic>
-        <p:nvPicPr>
-          <p:cNvPr id="5" name="Image 0" descr="CNN confusion matrix"/>
-          <p:cNvPicPr>
-            <a:picLocks noChangeAspect="1"/>
-          </p:cNvPicPr>
-          <p:nvPr/>
-        </p:nvPicPr>
-        <p:blipFill>
-          <a:blip r:embed="rId3"/>
-          <a:stretch>
-            <a:fillRect/>
-          </a:stretch>
-        </p:blipFill>
-        <p:spPr>
-          <a:xfrm>
-            <a:off x="800100" y="1280160"/>
-            <a:ext cx="3246120" cy="2501109"/>
-          </a:xfrm>
-          <a:prstGeom prst="rect">
-            <a:avLst/>
-          </a:prstGeom>
-        </p:spPr>
-      </p:pic>
-      <p:pic>
-        <p:nvPicPr>
-          <p:cNvPr id="6" name="Image 1" descr="Logistic regression confusion matrix"/>
-          <p:cNvPicPr>
-            <a:picLocks noChangeAspect="1"/>
-          </p:cNvPicPr>
-          <p:nvPr/>
-        </p:nvPicPr>
-        <p:blipFill>
-          <a:blip r:embed="rId4"/>
-          <a:stretch>
-            <a:fillRect/>
-          </a:stretch>
-        </p:blipFill>
-        <p:spPr>
-          <a:xfrm>
-            <a:off x="5097780" y="1280160"/>
-            <a:ext cx="3246120" cy="2501109"/>
-          </a:xfrm>
-          <a:prstGeom prst="rect">
-            <a:avLst/>
-          </a:prstGeom>
-        </p:spPr>
-      </p:pic>
-      <p:sp>
-        <p:nvSpPr>
-          <p:cNvPr id="7" name="Text 3"/>
-          <p:cNvSpPr txBox="1"/>
-          <p:nvPr/>
-        </p:nvSpPr>
-        <p:spPr>
-          <a:xfrm>
-            <a:off x="640080" y="3886200"/>
-            <a:ext cx="3566160" cy="685800"/>
-          </a:xfrm>
-          <a:prstGeom prst="rect">
-            <a:avLst/>
-          </a:prstGeom>
-          <a:noFill/>
-          <a:ln/>
-        </p:spPr>
-        <p:txBody>
-          <a:bodyPr wrap="square" lIns="0" tIns="0" rIns="0" bIns="0" rtlCol="0" anchor="t"/>
-          <a:lstStyle/>
-          <a:p>
-            <a:pPr marL="0" indent="0">
-              <a:buNone/>
-            </a:pPr>
-            <a:r>
-              <a:rPr lang="en-US" sz="1300" dirty="0">
-                <a:solidFill>
-                  <a:schemeClr val="tx2"/>
-                </a:solidFill>
-                <a:latin typeface="Calibri" pitchFamily="34" charset="0"/>
-                <a:ea typeface="Calibri" pitchFamily="34" charset="-122"/>
-                <a:cs typeface="Calibri" pitchFamily="34" charset="-120"/>
-              </a:rPr>
-              <a:t>CNN: banana ↔ hockey stick confused 67 and 72 times; mosquito 1,965 / 2,000 correct</a:t>
-            </a:r>
-            <a:endParaRPr lang="en-US" sz="1300" dirty="0"/>
-          </a:p>
-        </p:txBody>
-      </p:sp>
-      <p:sp>
-        <p:nvSpPr>
-          <p:cNvPr id="8" name="Text 4"/>
-          <p:cNvSpPr txBox="1"/>
-          <p:nvPr/>
-        </p:nvSpPr>
-        <p:spPr>
-          <a:xfrm>
-            <a:off x="4937760" y="3886200"/>
-            <a:ext cx="3566160" cy="685800"/>
-          </a:xfrm>
-          <a:prstGeom prst="rect">
-            <a:avLst/>
-          </a:prstGeom>
-          <a:noFill/>
-          <a:ln/>
-        </p:spPr>
-        <p:txBody>
-          <a:bodyPr wrap="square" lIns="0" tIns="0" rIns="0" bIns="0" rtlCol="0" anchor="t"/>
-          <a:lstStyle/>
-          <a:p>
-            <a:pPr marL="0" indent="0">
-              <a:buNone/>
-            </a:pPr>
-            <a:r>
-              <a:rPr lang="en-US" sz="1300" dirty="0">
-                <a:solidFill>
-                  <a:schemeClr val="tx2"/>
-                </a:solidFill>
-                <a:latin typeface="Calibri" pitchFamily="34" charset="0"/>
-                <a:ea typeface="Calibri" pitchFamily="34" charset="-122"/>
-                <a:cs typeface="Calibri" pitchFamily="34" charset="-120"/>
-              </a:rPr>
-              <a:t>Logistic regression: the same pair confused 364 and 238 times; mosquito 1,807 / 2,000 correct</a:t>
-            </a:r>
-            <a:endParaRPr lang="en-US" sz="1300" dirty="0"/>
-          </a:p>
-        </p:txBody>
-      </p:sp>
-      <p:sp>
-        <p:nvSpPr>
-          <p:cNvPr id="25" name="Slide Number Placeholder 0"/>
-          <p:cNvSpPr>
-            <a:spLocks noGrp="1"/>
-          </p:cNvSpPr>
-          <p:nvPr>
-            <p:ph type="sldNum" sz="quarter" idx="4294967295"/>
-          </p:nvPr>
-        </p:nvSpPr>
-        <p:spPr>
-          <a:xfrm>
-            <a:off x="8229600" y="4800600"/>
-            <a:ext cx="457200" cy="228600"/>
-          </a:xfrm>
-          <a:prstGeom prst="rect">
-            <a:avLst/>
-          </a:prstGeom>
-          <a:extLst>
-            <a:ext uri="{C572A759-6A51-4108-AA02-DFA0A04FC94B}">
-              <ma14:wrappingTextBoxFlag xmlns:ma14="http://schemas.microsoft.com/office/mac/drawingml/2011/main" xmlns="" val="0"/>
-            </a:ext>
-          </a:extLst>
-        </p:spPr>
-        <p:txBody>
-          <a:bodyPr/>
-          <a:lstStyle>
-            <a:lvl1pPr>
-              <a:defRPr sz="1000">
-                <a:solidFill>
-                  <a:schemeClr val="accent5"/>
-                </a:solidFill>
-              </a:defRPr>
-            </a:lvl1pPr>
-          </a:lstStyle>
-          <a:p>
-            <a:pPr algn="r"/>
-            <a:fld id="{F7021451-1387-4CA6-816F-3879F97B5CBC}" type="slidenum">
-              <a:rPr lang="en-US" b="0"/>
-              <a:t>8</a:t>
-            </a:fld>
-            <a:endParaRPr lang="en-US"/>
-          </a:p>
-        </p:txBody>
-      </p:sp>
-    </p:spTree>
-  </p:cSld>
-  <p:clrMapOvr>
-    <a:masterClrMapping/>
-  </p:clrMapOvr>
-</p:sld>
-</file>
-
-<file path=ppt/slides/slide9.xml><?xml version="1.0" encoding="utf-8"?>
 <p:sld xmlns:a="http://schemas.openxmlformats.org/drawingml/2006/main" xmlns:r="http://schemas.openxmlformats.org/officeDocument/2006/relationships" xmlns:p="http://schemas.openxmlformats.org/presentationml/2006/main">
   <p:cSld name="Slide 9">
     <p:spTree>
@@ -9879,6 +9041,463 @@
                 <a:cs typeface="Calibri" pitchFamily="34" charset="-120"/>
               </a:rPr>
               <a:t>Logistic regression is the pragmatic baseline: 83% accuracy in 15 seconds with near-instant inference. The CNN is the best model when accuracy matters. Timings are CPU-only and machine dependent.</a:t>
+            </a:r>
+            <a:endParaRPr lang="en-US" sz="1400" dirty="0"/>
+          </a:p>
+        </p:txBody>
+      </p:sp>
+      <p:sp>
+        <p:nvSpPr>
+          <p:cNvPr id="25" name="Slide Number Placeholder 0"/>
+          <p:cNvSpPr>
+            <a:spLocks noGrp="1"/>
+          </p:cNvSpPr>
+          <p:nvPr>
+            <p:ph type="sldNum" sz="quarter" idx="4294967295"/>
+          </p:nvPr>
+        </p:nvSpPr>
+        <p:spPr>
+          <a:xfrm>
+            <a:off x="8229600" y="4800600"/>
+            <a:ext cx="457200" cy="228600"/>
+          </a:xfrm>
+          <a:prstGeom prst="rect">
+            <a:avLst/>
+          </a:prstGeom>
+          <a:extLst>
+            <a:ext uri="{C572A759-6A51-4108-AA02-DFA0A04FC94B}">
+              <ma14:wrappingTextBoxFlag xmlns:ma14="http://schemas.microsoft.com/office/mac/drawingml/2011/main" xmlns="" val="0"/>
+            </a:ext>
+          </a:extLst>
+        </p:spPr>
+        <p:txBody>
+          <a:bodyPr/>
+          <a:lstStyle>
+            <a:lvl1pPr>
+              <a:defRPr sz="1000">
+                <a:solidFill>
+                  <a:schemeClr val="accent5"/>
+                </a:solidFill>
+              </a:defRPr>
+            </a:lvl1pPr>
+          </a:lstStyle>
+          <a:p>
+            <a:pPr algn="r"/>
+            <a:fld id="{F7021451-1387-4CA6-816F-3879F97B5CBC}" type="slidenum">
+              <a:rPr lang="en-US" b="0"/>
+              <a:t>8</a:t>
+            </a:fld>
+            <a:endParaRPr lang="en-US"/>
+          </a:p>
+        </p:txBody>
+      </p:sp>
+    </p:spTree>
+  </p:cSld>
+  <p:clrMapOvr>
+    <a:masterClrMapping/>
+  </p:clrMapOvr>
+</p:sld>
+</file>
+
+<file path=ppt/slides/slide9.xml><?xml version="1.0" encoding="utf-8"?>
+<p:sld xmlns:a="http://schemas.openxmlformats.org/drawingml/2006/main" xmlns:r="http://schemas.openxmlformats.org/officeDocument/2006/relationships" xmlns:p="http://schemas.openxmlformats.org/presentationml/2006/main">
+  <p:cSld name="Slide 10">
+    <p:spTree>
+      <p:nvGrpSpPr>
+        <p:cNvPr id="1" name=""/>
+        <p:cNvGrpSpPr/>
+        <p:nvPr/>
+      </p:nvGrpSpPr>
+      <p:grpSpPr>
+        <a:xfrm>
+          <a:off x="0" y="0"/>
+          <a:ext cx="0" cy="0"/>
+          <a:chOff x="0" y="0"/>
+          <a:chExt cx="0" cy="0"/>
+        </a:xfrm>
+      </p:grpSpPr>
+      <p:sp>
+        <p:nvSpPr>
+          <p:cNvPr id="2" name="Text 0"/>
+          <p:cNvSpPr>
+            <a:spLocks noGrp="1"/>
+          </p:cNvSpPr>
+          <p:nvPr>
+            <p:ph type="title" idx="100" hasCustomPrompt="1"/>
+          </p:nvPr>
+        </p:nvSpPr>
+        <p:spPr>
+          <a:xfrm>
+            <a:off x="457200" y="274320"/>
+            <a:ext cx="8229600" cy="731520"/>
+          </a:xfrm>
+          <a:prstGeom prst="rect">
+            <a:avLst/>
+          </a:prstGeom>
+          <a:noFill/>
+          <a:ln/>
+        </p:spPr>
+        <p:txBody>
+          <a:bodyPr wrap="square" lIns="0" tIns="0" rIns="0" bIns="0" rtlCol="0" anchor="ctr"/>
+          <a:lstStyle/>
+          <a:p>
+            <a:pPr marL="0" indent="0" algn="l">
+              <a:buNone/>
+            </a:pPr>
+            <a:r>
+              <a:rPr lang="en-US" sz="2600" b="1" dirty="0">
+                <a:solidFill>
+                  <a:schemeClr val="tx1"/>
+                </a:solidFill>
+                <a:latin typeface="Cambria" pitchFamily="34" charset="0"/>
+                <a:ea typeface="Cambria" pitchFamily="34" charset="-122"/>
+                <a:cs typeface="Cambria" pitchFamily="34" charset="-120"/>
+              </a:rPr>
+              <a:t>Conclusions and limitations</a:t>
+            </a:r>
+            <a:endParaRPr lang="en-US" sz="2600" dirty="0"/>
+          </a:p>
+        </p:txBody>
+      </p:sp>
+      <p:sp>
+        <p:nvSpPr>
+          <p:cNvPr id="3" name="Shape 1"/>
+          <p:cNvSpPr/>
+          <p:nvPr/>
+        </p:nvSpPr>
+        <p:spPr>
+          <a:xfrm>
+            <a:off x="457200" y="1188720"/>
+            <a:ext cx="4023360" cy="3383280"/>
+          </a:xfrm>
+          <a:prstGeom prst="roundRect">
+            <a:avLst>
+              <a:gd name="adj" fmla="val 3243"/>
+            </a:avLst>
+          </a:prstGeom>
+          <a:solidFill>
+            <a:schemeClr val="bg2"/>
+          </a:solidFill>
+          <a:ln w="12700">
+            <a:solidFill>
+              <a:schemeClr val="bg2"/>
+            </a:solidFill>
+            <a:prstDash val="solid"/>
+          </a:ln>
+        </p:spPr>
+      </p:sp>
+      <p:sp>
+        <p:nvSpPr>
+          <p:cNvPr id="4" name="Shape 2"/>
+          <p:cNvSpPr/>
+          <p:nvPr/>
+        </p:nvSpPr>
+        <p:spPr>
+          <a:xfrm>
+            <a:off x="4663440" y="1188720"/>
+            <a:ext cx="4023360" cy="3383280"/>
+          </a:xfrm>
+          <a:prstGeom prst="roundRect">
+            <a:avLst>
+              <a:gd name="adj" fmla="val 3243"/>
+            </a:avLst>
+          </a:prstGeom>
+          <a:solidFill>
+            <a:schemeClr val="bg2"/>
+          </a:solidFill>
+          <a:ln w="12700">
+            <a:solidFill>
+              <a:schemeClr val="bg2"/>
+            </a:solidFill>
+            <a:prstDash val="solid"/>
+          </a:ln>
+        </p:spPr>
+      </p:sp>
+      <p:sp>
+        <p:nvSpPr>
+          <p:cNvPr id="5" name="Text 3"/>
+          <p:cNvSpPr txBox="1"/>
+          <p:nvPr/>
+        </p:nvSpPr>
+        <p:spPr>
+          <a:xfrm>
+            <a:off x="685800" y="1325880"/>
+            <a:ext cx="3566160" cy="365760"/>
+          </a:xfrm>
+          <a:prstGeom prst="rect">
+            <a:avLst/>
+          </a:prstGeom>
+          <a:noFill/>
+          <a:ln/>
+        </p:spPr>
+        <p:txBody>
+          <a:bodyPr wrap="square" lIns="0" tIns="0" rIns="0" bIns="0" rtlCol="0" anchor="ctr"/>
+          <a:lstStyle/>
+          <a:p>
+            <a:pPr marL="0" indent="0">
+              <a:buNone/>
+            </a:pPr>
+            <a:r>
+              <a:rPr lang="en-US" sz="1800" b="1" dirty="0">
+                <a:solidFill>
+                  <a:schemeClr val="accent2"/>
+                </a:solidFill>
+                <a:latin typeface="Calibri" pitchFamily="34" charset="0"/>
+                <a:ea typeface="Calibri" pitchFamily="34" charset="-122"/>
+                <a:cs typeface="Calibri" pitchFamily="34" charset="-120"/>
+              </a:rPr>
+              <a:t>What we found</a:t>
+            </a:r>
+            <a:endParaRPr lang="en-US" sz="1800" dirty="0"/>
+          </a:p>
+        </p:txBody>
+      </p:sp>
+      <p:sp>
+        <p:nvSpPr>
+          <p:cNvPr id="6" name="Text 4"/>
+          <p:cNvSpPr txBox="1"/>
+          <p:nvPr/>
+        </p:nvSpPr>
+        <p:spPr>
+          <a:xfrm>
+            <a:off x="685800" y="1783080"/>
+            <a:ext cx="3611880" cy="2697480"/>
+          </a:xfrm>
+          <a:prstGeom prst="rect">
+            <a:avLst/>
+          </a:prstGeom>
+          <a:noFill/>
+          <a:ln/>
+        </p:spPr>
+        <p:txBody>
+          <a:bodyPr wrap="square" lIns="0" tIns="0" rIns="0" bIns="0" rtlCol="0" anchor="t"/>
+          <a:lstStyle/>
+          <a:p>
+            <a:pPr marL="342900" indent="-342900">
+              <a:spcAft>
+                <a:spcPts val="800"/>
+              </a:spcAft>
+              <a:buSzPct val="100000"/>
+              <a:buChar char="•"/>
+            </a:pPr>
+            <a:r>
+              <a:rPr lang="en-US" sz="1400" dirty="0">
+                <a:solidFill>
+                  <a:schemeClr val="tx1"/>
+                </a:solidFill>
+                <a:latin typeface="Calibri" pitchFamily="34" charset="0"/>
+                <a:ea typeface="Calibri" pitchFamily="34" charset="-122"/>
+                <a:cs typeface="Calibri" pitchFamily="34" charset="-120"/>
+              </a:rPr>
+              <a:t>CNN wins on every metric (95.0% accuracy)</a:t>
+            </a:r>
+            <a:endParaRPr lang="en-US" sz="1400" dirty="0"/>
+          </a:p>
+          <a:p>
+            <a:pPr marL="342900" indent="-342900">
+              <a:spcAft>
+                <a:spcPts val="800"/>
+              </a:spcAft>
+              <a:buSzPct val="100000"/>
+              <a:buChar char="•"/>
+            </a:pPr>
+            <a:r>
+              <a:rPr lang="en-US" sz="1400" dirty="0">
+                <a:solidFill>
+                  <a:schemeClr val="tx1"/>
+                </a:solidFill>
+                <a:latin typeface="Calibri" pitchFamily="34" charset="0"/>
+                <a:ea typeface="Calibri" pitchFamily="34" charset="-122"/>
+                <a:cs typeface="Calibri" pitchFamily="34" charset="-120"/>
+              </a:rPr>
+              <a:t>Spatial features beat raw-pixel models on sketches</a:t>
+            </a:r>
+            <a:endParaRPr lang="en-US" sz="1400" dirty="0"/>
+          </a:p>
+          <a:p>
+            <a:pPr marL="342900" indent="-342900">
+              <a:spcAft>
+                <a:spcPts val="800"/>
+              </a:spcAft>
+              <a:buSzPct val="100000"/>
+              <a:buChar char="•"/>
+            </a:pPr>
+            <a:r>
+              <a:rPr lang="en-US" sz="1400" dirty="0">
+                <a:solidFill>
+                  <a:schemeClr val="tx1"/>
+                </a:solidFill>
+                <a:latin typeface="Calibri" pitchFamily="34" charset="0"/>
+                <a:ea typeface="Calibri" pitchFamily="34" charset="-122"/>
+                <a:cs typeface="Calibri" pitchFamily="34" charset="-120"/>
+              </a:rPr>
+              <a:t>RBF is the only SVM kernel competitive with logistic regression</a:t>
+            </a:r>
+            <a:endParaRPr lang="en-US" sz="1400" dirty="0"/>
+          </a:p>
+          <a:p>
+            <a:pPr marL="342900" indent="-342900">
+              <a:spcAft>
+                <a:spcPts val="800"/>
+              </a:spcAft>
+              <a:buSzPct val="100000"/>
+              <a:buChar char="•"/>
+            </a:pPr>
+            <a:r>
+              <a:rPr lang="en-US" sz="1400" dirty="0">
+                <a:solidFill>
+                  <a:schemeClr val="tx1"/>
+                </a:solidFill>
+                <a:latin typeface="Calibri" pitchFamily="34" charset="0"/>
+                <a:ea typeface="Calibri" pitchFamily="34" charset="-122"/>
+                <a:cs typeface="Calibri" pitchFamily="34" charset="-120"/>
+              </a:rPr>
+              <a:t>Banana vs hockey stick is the hardest pair</a:t>
+            </a:r>
+            <a:endParaRPr lang="en-US" sz="1400" dirty="0"/>
+          </a:p>
+        </p:txBody>
+      </p:sp>
+      <p:sp>
+        <p:nvSpPr>
+          <p:cNvPr id="7" name="Text 5"/>
+          <p:cNvSpPr txBox="1"/>
+          <p:nvPr/>
+        </p:nvSpPr>
+        <p:spPr>
+          <a:xfrm>
+            <a:off x="4892040" y="1325880"/>
+            <a:ext cx="3566160" cy="365760"/>
+          </a:xfrm>
+          <a:prstGeom prst="rect">
+            <a:avLst/>
+          </a:prstGeom>
+          <a:noFill/>
+          <a:ln/>
+        </p:spPr>
+        <p:txBody>
+          <a:bodyPr wrap="square" lIns="0" tIns="0" rIns="0" bIns="0" rtlCol="0" anchor="ctr"/>
+          <a:lstStyle/>
+          <a:p>
+            <a:pPr marL="0" indent="0">
+              <a:buNone/>
+            </a:pPr>
+            <a:r>
+              <a:rPr lang="en-US" sz="1800" b="1" dirty="0">
+                <a:solidFill>
+                  <a:schemeClr val="accent3"/>
+                </a:solidFill>
+                <a:latin typeface="Calibri" pitchFamily="34" charset="0"/>
+                <a:ea typeface="Calibri" pitchFamily="34" charset="-122"/>
+                <a:cs typeface="Calibri" pitchFamily="34" charset="-120"/>
+              </a:rPr>
+              <a:t>Caveats and next steps</a:t>
+            </a:r>
+            <a:endParaRPr lang="en-US" sz="1800" dirty="0"/>
+          </a:p>
+        </p:txBody>
+      </p:sp>
+      <p:sp>
+        <p:nvSpPr>
+          <p:cNvPr id="8" name="Text 6"/>
+          <p:cNvSpPr txBox="1"/>
+          <p:nvPr/>
+        </p:nvSpPr>
+        <p:spPr>
+          <a:xfrm>
+            <a:off x="4892040" y="1783080"/>
+            <a:ext cx="3611880" cy="2697480"/>
+          </a:xfrm>
+          <a:prstGeom prst="rect">
+            <a:avLst/>
+          </a:prstGeom>
+          <a:noFill/>
+          <a:ln/>
+        </p:spPr>
+        <p:txBody>
+          <a:bodyPr wrap="square" lIns="0" tIns="0" rIns="0" bIns="0" rtlCol="0" anchor="t"/>
+          <a:lstStyle/>
+          <a:p>
+            <a:pPr marL="342900" indent="-342900">
+              <a:spcAft>
+                <a:spcPts val="800"/>
+              </a:spcAft>
+              <a:buSzPct val="100000"/>
+              <a:buChar char="•"/>
+            </a:pPr>
+            <a:r>
+              <a:rPr lang="en-US" sz="1400" dirty="0">
+                <a:solidFill>
+                  <a:schemeClr val="tx1"/>
+                </a:solidFill>
+                <a:latin typeface="Calibri" pitchFamily="34" charset="0"/>
+                <a:ea typeface="Calibri" pitchFamily="34" charset="-122"/>
+                <a:cs typeface="Calibri" pitchFamily="34" charset="-120"/>
+              </a:rPr>
+              <a:t>SVMs hit the 500-iteration cap and were untuned</a:t>
+            </a:r>
+            <a:endParaRPr lang="en-US" sz="1400" dirty="0"/>
+          </a:p>
+          <a:p>
+            <a:pPr marL="342900" indent="-342900">
+              <a:spcAft>
+                <a:spcPts val="800"/>
+              </a:spcAft>
+              <a:buSzPct val="100000"/>
+              <a:buChar char="•"/>
+            </a:pPr>
+            <a:r>
+              <a:rPr lang="en-US" sz="1400" dirty="0">
+                <a:solidFill>
+                  <a:schemeClr val="tx1"/>
+                </a:solidFill>
+                <a:latin typeface="Calibri" pitchFamily="34" charset="0"/>
+                <a:ea typeface="Calibri" pitchFamily="34" charset="-122"/>
+                <a:cs typeface="Calibri" pitchFamily="34" charset="-120"/>
+              </a:rPr>
+              <a:t>No validation curves, so overfitting is unmeasured</a:t>
+            </a:r>
+            <a:endParaRPr lang="en-US" sz="1400" dirty="0"/>
+          </a:p>
+          <a:p>
+            <a:pPr marL="342900" indent="-342900">
+              <a:spcAft>
+                <a:spcPts val="800"/>
+              </a:spcAft>
+              <a:buSzPct val="100000"/>
+              <a:buChar char="•"/>
+            </a:pPr>
+            <a:r>
+              <a:rPr lang="en-US" sz="1400" dirty="0">
+                <a:solidFill>
+                  <a:schemeClr val="tx1"/>
+                </a:solidFill>
+                <a:latin typeface="Calibri" pitchFamily="34" charset="0"/>
+                <a:ea typeface="Calibri" pitchFamily="34" charset="-122"/>
+                <a:cs typeface="Calibri" pitchFamily="34" charset="-120"/>
+              </a:rPr>
+              <a:t>Transfer learning not run: pretrained weights are outside the three allowed inputs</a:t>
+            </a:r>
+            <a:endParaRPr lang="en-US" sz="1400" dirty="0"/>
+          </a:p>
+          <a:p>
+            <a:pPr marL="342900" indent="-342900">
+              <a:spcAft>
+                <a:spcPts val="800"/>
+              </a:spcAft>
+              <a:buSzPct val="100000"/>
+              <a:buChar char="•"/>
+            </a:pPr>
+            <a:r>
+              <a:rPr lang="en-US" sz="1400" dirty="0">
+                <a:solidFill>
+                  <a:schemeClr val="tx1"/>
+                </a:solidFill>
+                <a:latin typeface="Calibri" pitchFamily="34" charset="0"/>
+                <a:ea typeface="Calibri" pitchFamily="34" charset="-122"/>
+                <a:cs typeface="Calibri" pitchFamily="34" charset="-120"/>
+              </a:rPr>
+              <a:t>Next: tune SVMs, add augmentation and early stopping</a:t>
             </a:r>
             <a:endParaRPr lang="en-US" sz="1400" dirty="0"/>
           </a:p>

</xml_diff>